<commit_message>
v1.6: Parte 1 in un file con schede, nuova home e indice
</commit_message>
<xml_diff>
--- a/AI Parte 1, Presentazione.pptx
+++ b/AI Parte 1, Presentazione.pptx
@@ -119,46 +119,46 @@
   <p:extLst>
     <p:ext uri="{521415D9-36F7-43E2-AB2F-B90AF26B5E84}">
       <p14:sectionLst xmlns:p14="http://schemas.microsoft.com/office/powerpoint/2010/main">
-        <p14:section name="Apertura" id="{7fa005f6-ae5f-134b-ceab-920fc8db923c}">
+        <p14:section name="Apertura" id="{cf1ea5b6-b2b5-41ac-43ca-01faa4f0e323}">
           <p14:sldIdLst>
             <p14:sldId id="256"/>
             <p14:sldId id="257"/>
           </p14:sldIdLst>
         </p14:section>
-        <p14:section name="Perché" id="{68c7c518-0364-4677-b4ea-6f02db3a97ad}">
+        <p14:section name="Perché" id="{1cbac470-3cd6-69ba-50f0-cb67e859a1a1}">
           <p14:sldIdLst>
             <p14:sldId id="258"/>
             <p14:sldId id="259"/>
             <p14:sldId id="260"/>
           </p14:sldIdLst>
         </p14:section>
-        <p14:section name="Capire" id="{341d4204-9767-bbf7-ff59-879de878191a}">
+        <p14:section name="Capire" id="{fda675f1-2c65-71a3-8627-d107f94bcfdc}">
           <p14:sldIdLst>
             <p14:sldId id="261"/>
           </p14:sldIdLst>
         </p14:section>
-        <p14:section name="Regole chiave" id="{0d68ce2f-ee7a-f11d-6c36-12ec74e8dc5c}">
+        <p14:section name="Regole chiave" id="{3f028836-9aa1-85c0-36b7-ca8fe765085c}">
           <p14:sldIdLst>
             <p14:sldId id="262"/>
           </p14:sldIdLst>
         </p14:section>
-        <p14:section name="In azienda" id="{00852f20-7b37-aa47-19c0-57a82ada4e7d}">
+        <p14:section name="In azienda" id="{6bab4054-576a-4e81-5f1e-c614ba7a489e}">
           <p14:sldIdLst>
             <p14:sldId id="263"/>
           </p14:sldIdLst>
         </p14:section>
-        <p14:section name="Il materiale" id="{bc192994-2d2f-a7ca-7afc-6294ec2b389a}">
+        <p14:section name="Il materiale" id="{a44a6aa4-0619-e521-fcaa-99850474527a}">
           <p14:sldIdLst>
             <p14:sldId id="264"/>
           </p14:sldIdLst>
         </p14:section>
-        <p14:section name="Adesso" id="{4fcc21e5-0cdf-3601-4fd1-798f4f75242b}">
+        <p14:section name="Adesso" id="{3989a252-17e0-6b42-f2fe-377c28eac48d}">
           <p14:sldIdLst>
             <p14:sldId id="265"/>
             <p14:sldId id="266"/>
           </p14:sldIdLst>
         </p14:section>
-        <p14:section name="Chiusura" id="{8feffbcb-0a17-3ebb-6438-702c6bfc1565}">
+        <p14:section name="Chiusura" id="{710b032b-3b76-a812-a5c4-e1550f12cbd2}">
           <p14:sldIdLst>
             <p14:sldId id="267"/>
             <p14:sldId id="268"/>
@@ -744,7 +744,7 @@
           <a:p>
             <a:r>
               <a:rPr lang="en-US" dirty="0"/>
-              <a:t>Il materiale è un file da aprire nel browser, funziona anche senza internet. Mostrate dal vivo dove sono l’interruttore della lingua, il menu dei capitoli e la checklist. Il programma è indicativo: decidetelo con il vostro responsabile.</a:t>
+              <a:t>Il materiale si apre da un link nel browser, anche dal telefono, e non serve nessun account. Mostrate dal vivo dove sono l’interruttore della lingua, il menu dei capitoli e la checklist. Il programma è indicativo: decidetelo con il vostro responsabile.</a:t>
             </a:r>
             <a:endParaRPr lang="en-US" dirty="0"/>
           </a:p>
@@ -4353,7 +4353,7 @@
                 <a:ea typeface="Arial" pitchFamily="34" charset="-122"/>
                 <a:cs typeface="Arial" pitchFamily="34" charset="-120"/>
               </a:rPr>
-              <a:t>Apri il file nel browser, anche dal telefono</a:t>
+              <a:t>Apri il link nel browser, anche dal telefono</a:t>
             </a:r>
             <a:endParaRPr lang="en-US" sz="1500" dirty="0"/>
           </a:p>

</xml_diff>

<commit_message>
v1.7: home chiara, testi rivisti, tooltip glossario, crediti
</commit_message>
<xml_diff>
--- a/AI Parte 1, Presentazione.pptx
+++ b/AI Parte 1, Presentazione.pptx
@@ -119,46 +119,46 @@
   <p:extLst>
     <p:ext uri="{521415D9-36F7-43E2-AB2F-B90AF26B5E84}">
       <p14:sectionLst xmlns:p14="http://schemas.microsoft.com/office/powerpoint/2010/main">
-        <p14:section name="Apertura" id="{cf1ea5b6-b2b5-41ac-43ca-01faa4f0e323}">
+        <p14:section name="Apertura" id="{145ec069-4118-8c12-9274-7dfb17d0689b}">
           <p14:sldIdLst>
             <p14:sldId id="256"/>
             <p14:sldId id="257"/>
           </p14:sldIdLst>
         </p14:section>
-        <p14:section name="Perché" id="{1cbac470-3cd6-69ba-50f0-cb67e859a1a1}">
+        <p14:section name="Perché" id="{fc42f74a-ab24-069b-b8a4-008f02596223}">
           <p14:sldIdLst>
             <p14:sldId id="258"/>
             <p14:sldId id="259"/>
             <p14:sldId id="260"/>
           </p14:sldIdLst>
         </p14:section>
-        <p14:section name="Capire" id="{fda675f1-2c65-71a3-8627-d107f94bcfdc}">
+        <p14:section name="Capire" id="{fa0cbade-0907-8c70-a765-3a9ec3d2c26c}">
           <p14:sldIdLst>
             <p14:sldId id="261"/>
           </p14:sldIdLst>
         </p14:section>
-        <p14:section name="Regole chiave" id="{3f028836-9aa1-85c0-36b7-ca8fe765085c}">
+        <p14:section name="Regole chiave" id="{07c2e3cc-ec22-ce88-eed4-d92c8aacf638}">
           <p14:sldIdLst>
             <p14:sldId id="262"/>
           </p14:sldIdLst>
         </p14:section>
-        <p14:section name="In azienda" id="{6bab4054-576a-4e81-5f1e-c614ba7a489e}">
+        <p14:section name="In azienda" id="{1b5dce08-6d34-20e6-775a-d54e351822fe}">
           <p14:sldIdLst>
             <p14:sldId id="263"/>
           </p14:sldIdLst>
         </p14:section>
-        <p14:section name="Il materiale" id="{a44a6aa4-0619-e521-fcaa-99850474527a}">
+        <p14:section name="Il materiale" id="{8fde333d-8eee-c87e-543d-427180f2f67a}">
           <p14:sldIdLst>
             <p14:sldId id="264"/>
           </p14:sldIdLst>
         </p14:section>
-        <p14:section name="Adesso" id="{3989a252-17e0-6b42-f2fe-377c28eac48d}">
+        <p14:section name="Adesso" id="{06353669-71fe-c9de-b836-8d6e8ad643c0}">
           <p14:sldIdLst>
             <p14:sldId id="265"/>
             <p14:sldId id="266"/>
           </p14:sldIdLst>
         </p14:section>
-        <p14:section name="Chiusura" id="{710b032b-3b76-a812-a5c4-e1550f12cbd2}">
+        <p14:section name="Chiusura" id="{267defe5-f82f-9f12-6f2d-923e869f18fd}">
           <p14:sldIdLst>
             <p14:sldId id="267"/>
             <p14:sldId id="268"/>
@@ -568,7 +568,7 @@
           <a:p>
             <a:r>
               <a:rPr lang="en-US" dirty="0"/>
-              <a:t>Oggi parliamo di intelligenza artificiale al lavoro: cosa fa bene, dove sbaglia, quali dati non darle mai e come usarla bene. Non serve saper programmare. Come per la sicurezza, oggi c’è l’introduzione e il resto è nel materiale.</a:t>
+              <a:t>Oggi parliamo di intelligenza artificiale al lavoro: cosa fa bene, dove sbaglia, quali dati non darle mai e come usarla bene. Non serve saper programmare. Come per la sicurezza: oggi l’introduzione, il resto è nel materiale.</a:t>
             </a:r>
             <a:endParaRPr lang="en-US" dirty="0"/>
           </a:p>
@@ -1008,7 +1008,7 @@
           <a:p>
             <a:r>
               <a:rPr lang="en-US" dirty="0"/>
-              <a:t>Quattro temi, che nel materiale diventano le sezioni A, B, C e D. Prima capiamo cos’è e perché sbaglia. Poi la sicurezza: quali dati sì e quali no. Poi come usarla bene ogni giorno. Infine come un’azienda si organizza per farla lavorare davvero: dati in ordine, connettori, skill e agenti.</a:t>
+              <a:t>Quattro temi, che nel materiale sono le sezioni A, B, C e D. Prima cos’è e perché sbaglia. Poi la sicurezza: quali dati sì e quali no. Poi come usarla bene ogni giorno. Infine come un’azienda si organizza per farla lavorare davvero: dati in ordine, connettori, skill e agenti.</a:t>
             </a:r>
             <a:endParaRPr lang="en-US" dirty="0"/>
           </a:p>
@@ -1184,7 +1184,7 @@
           <a:p>
             <a:r>
               <a:rPr lang="en-US" dirty="0"/>
-              <a:t>Tre numeri. Due persone su tre usano l’AI con account personali, quindi con dati aziendali fuori dal controllo dell’azienda. I truffatori la usano già per scrivere email perfette. E secondo Gartner, entro il 2026 sarà abbandonato il 60% dei progetti AI senza dati pronti.</a:t>
+              <a:t>Tre numeri. Due persone su tre usano l’AI con account personali: dati aziendali fuori dal controllo dell’azienda. I truffatori la usano già per scrivere email perfette. E secondo Gartner, entro il 2026 sarà abbandonato il 60% dei progetti AI senza dati pronti.</a:t>
             </a:r>
             <a:endParaRPr lang="en-US" dirty="0"/>
           </a:p>
@@ -1448,7 +1448,7 @@
           <a:p>
             <a:r>
               <a:rPr lang="en-US" dirty="0"/>
-              <a:t>Le stesse quattro classi di dati della Sicurezza Parte 2, applicate all’AI. Pubblico sì. Interno solo negli strumenti approvati dall’azienda. Confidenziale solo lì e anonimizzato, salvo uno strumento che l’azienda approva per iscritto anche per i dati veri, per esempio l’account aziendale. Segreto mai, in nessuna AI. E l’AI non deve mai poter fare pagamenti o cancellare file e account da sola.</a:t>
+              <a:t>Le quattro classi di dati della Sicurezza Parte 2, applicate all’AI. Pubblico sì. Interno solo negli strumenti approvati dall’azienda. Confidenziale solo lì e anonimizzato, salvo uno strumento approvato per iscritto anche per i dati veri, per esempio l’account aziendale. Segreto mai, in nessuna AI. E l’AI non deve mai poter fare pagamenti o cancellare file e account da sola.</a:t>
             </a:r>
             <a:endParaRPr lang="en-US" dirty="0"/>
           </a:p>
@@ -6048,7 +6048,7 @@
         </p:nvSpPr>
         <p:spPr>
           <a:xfrm>
-            <a:off x="685800" y="5989320"/>
+            <a:off x="685800" y="5760720"/>
             <a:ext cx="10820095" cy="256032"/>
           </a:xfrm>
           <a:prstGeom prst="rect">
@@ -6076,6 +6076,45 @@
               <a:t>Tutte le fonti, con i link, sono anche nell’ultimo capitolo del materiale.</a:t>
             </a:r>
             <a:endParaRPr lang="en-US" sz="1100" dirty="0"/>
+          </a:p>
+        </p:txBody>
+      </p:sp>
+      <p:sp>
+        <p:nvSpPr>
+          <p:cNvPr id="10" name="Crediti"/>
+          <p:cNvSpPr txBox="1"/>
+          <p:nvPr/>
+        </p:nvSpPr>
+        <p:spPr>
+          <a:xfrm>
+            <a:off x="685800" y="6016752"/>
+            <a:ext cx="10820095" cy="329184"/>
+          </a:xfrm>
+          <a:prstGeom prst="rect">
+            <a:avLst/>
+          </a:prstGeom>
+          <a:noFill/>
+          <a:ln/>
+        </p:spPr>
+        <p:txBody>
+          <a:bodyPr wrap="square" lIns="0" tIns="0" rIns="0" bIns="0" rtlCol="0" anchor="t"/>
+          <a:lstStyle/>
+          <a:p>
+            <a:pPr indent="0" marL="0">
+              <a:buNone/>
+            </a:pPr>
+            <a:r>
+              <a:rPr lang="en-US" sz="1000" dirty="0">
+                <a:solidFill>
+                  <a:schemeClr val="accent6"/>
+                </a:solidFill>
+                <a:latin typeface="Arial" pitchFamily="34" charset="0"/>
+                <a:ea typeface="Arial" pitchFamily="34" charset="-122"/>
+                <a:cs typeface="Arial" pitchFamily="34" charset="-120"/>
+              </a:rPr>
+              <a:t>© 2026 Aron Clementi. Materiale formativo a scopo informativo: non sostituisce una consulenza legale o tecnica né le regole della tua azienda. Fonti verificate alla data indicata; strumenti e prezzi cambiano.</a:t>
+            </a:r>
+            <a:endParaRPr lang="en-US" sz="1000" dirty="0"/>
           </a:p>
         </p:txBody>
       </p:sp>
@@ -9059,7 +9098,7 @@
                 <a:ea typeface="Arial" pitchFamily="34" charset="-122"/>
                 <a:cs typeface="Arial" pitchFamily="34" charset="-120"/>
               </a:rPr>
-              <a:t>Chiedi le fonti e ricontrolla nomi, date e numeri. Per i calcoli, fagli usare Excel o il codice.</a:t>
+              <a:t>Chiedi le fonti e ricontrolla nomi, date e numeri. Per i calcoli, falle usare Excel o il codice.</a:t>
             </a:r>
             <a:endParaRPr lang="en-US" sz="1500" dirty="0"/>
           </a:p>

</xml_diff>

<commit_message>
Dichiarazione di sicurezza al posto del Policy Set
</commit_message>
<xml_diff>
--- a/AI Parte 1, Presentazione.pptx
+++ b/AI Parte 1, Presentazione.pptx
@@ -119,46 +119,46 @@
   <p:extLst>
     <p:ext uri="{521415D9-36F7-43E2-AB2F-B90AF26B5E84}">
       <p14:sectionLst xmlns:p14="http://schemas.microsoft.com/office/powerpoint/2010/main">
-        <p14:section name="Apertura" id="{145ec069-4118-8c12-9274-7dfb17d0689b}">
+        <p14:section name="Apertura" id="{44647646-e91b-012b-710a-fe5881409049}">
           <p14:sldIdLst>
             <p14:sldId id="256"/>
             <p14:sldId id="257"/>
           </p14:sldIdLst>
         </p14:section>
-        <p14:section name="Perché" id="{fc42f74a-ab24-069b-b8a4-008f02596223}">
+        <p14:section name="Perché" id="{c8dcd249-b193-5bf4-a8bc-120f26b44c36}">
           <p14:sldIdLst>
             <p14:sldId id="258"/>
             <p14:sldId id="259"/>
             <p14:sldId id="260"/>
           </p14:sldIdLst>
         </p14:section>
-        <p14:section name="Capire" id="{fa0cbade-0907-8c70-a765-3a9ec3d2c26c}">
+        <p14:section name="Capire" id="{4440a227-4d31-de50-8517-eaddc606923c}">
           <p14:sldIdLst>
             <p14:sldId id="261"/>
           </p14:sldIdLst>
         </p14:section>
-        <p14:section name="Regole chiave" id="{07c2e3cc-ec22-ce88-eed4-d92c8aacf638}">
+        <p14:section name="Regole chiave" id="{dfcd32c3-1b35-66b8-9eaa-6bbb97136e44}">
           <p14:sldIdLst>
             <p14:sldId id="262"/>
           </p14:sldIdLst>
         </p14:section>
-        <p14:section name="In azienda" id="{1b5dce08-6d34-20e6-775a-d54e351822fe}">
+        <p14:section name="In azienda" id="{ac0659a8-1420-dba4-3f32-912b0d692f39}">
           <p14:sldIdLst>
             <p14:sldId id="263"/>
           </p14:sldIdLst>
         </p14:section>
-        <p14:section name="Il materiale" id="{8fde333d-8eee-c87e-543d-427180f2f67a}">
+        <p14:section name="Il materiale" id="{7f77b256-fe76-5a68-a04f-c2450b228790}">
           <p14:sldIdLst>
             <p14:sldId id="264"/>
           </p14:sldIdLst>
         </p14:section>
-        <p14:section name="Adesso" id="{06353669-71fe-c9de-b836-8d6e8ad643c0}">
+        <p14:section name="Adesso" id="{de275968-ab7b-37be-3af7-91fb872e5bbe}">
           <p14:sldIdLst>
             <p14:sldId id="265"/>
             <p14:sldId id="266"/>
           </p14:sldIdLst>
         </p14:section>
-        <p14:section name="Chiusura" id="{267defe5-f82f-9f12-6f2d-923e869f18fd}">
+        <p14:section name="Chiusura" id="{fb679aca-bad8-700b-bec6-c00d922c40e3}">
           <p14:sldIdLst>
             <p14:sldId id="267"/>
             <p14:sldId id="268"/>

</xml_diff>

<commit_message>
v1.7: 20 nuovi punti da confronto PSP, nessun riferimento alla dichiarazione
</commit_message>
<xml_diff>
--- a/AI Parte 1, Presentazione.pptx
+++ b/AI Parte 1, Presentazione.pptx
@@ -119,46 +119,46 @@
   <p:extLst>
     <p:ext uri="{521415D9-36F7-43E2-AB2F-B90AF26B5E84}">
       <p14:sectionLst xmlns:p14="http://schemas.microsoft.com/office/powerpoint/2010/main">
-        <p14:section name="Apertura" id="{44647646-e91b-012b-710a-fe5881409049}">
+        <p14:section name="Apertura" id="{44afbf48-d307-72d2-a021-a66cac9cbdda}">
           <p14:sldIdLst>
             <p14:sldId id="256"/>
             <p14:sldId id="257"/>
           </p14:sldIdLst>
         </p14:section>
-        <p14:section name="Perché" id="{c8dcd249-b193-5bf4-a8bc-120f26b44c36}">
+        <p14:section name="Perché" id="{245d62f3-830c-f04a-c490-1aaf9418d089}">
           <p14:sldIdLst>
             <p14:sldId id="258"/>
             <p14:sldId id="259"/>
             <p14:sldId id="260"/>
           </p14:sldIdLst>
         </p14:section>
-        <p14:section name="Capire" id="{4440a227-4d31-de50-8517-eaddc606923c}">
+        <p14:section name="Capire" id="{8e9705c2-c46a-5fce-6e96-14becf825581}">
           <p14:sldIdLst>
             <p14:sldId id="261"/>
           </p14:sldIdLst>
         </p14:section>
-        <p14:section name="Regole chiave" id="{dfcd32c3-1b35-66b8-9eaa-6bbb97136e44}">
+        <p14:section name="Regole chiave" id="{42672046-1c30-4915-dd89-b207589e0704}">
           <p14:sldIdLst>
             <p14:sldId id="262"/>
           </p14:sldIdLst>
         </p14:section>
-        <p14:section name="In azienda" id="{ac0659a8-1420-dba4-3f32-912b0d692f39}">
+        <p14:section name="In azienda" id="{9fc5b7c6-3977-aa78-097b-d8da3ee20ed2}">
           <p14:sldIdLst>
             <p14:sldId id="263"/>
           </p14:sldIdLst>
         </p14:section>
-        <p14:section name="Il materiale" id="{7f77b256-fe76-5a68-a04f-c2450b228790}">
+        <p14:section name="Il materiale" id="{9766cd91-c801-055f-fab1-ff59c2be33d4}">
           <p14:sldIdLst>
             <p14:sldId id="264"/>
           </p14:sldIdLst>
         </p14:section>
-        <p14:section name="Adesso" id="{de275968-ab7b-37be-3af7-91fb872e5bbe}">
+        <p14:section name="Adesso" id="{fa5be2f2-54dd-3547-0333-413858884d7d}">
           <p14:sldIdLst>
             <p14:sldId id="265"/>
             <p14:sldId id="266"/>
           </p14:sldIdLst>
         </p14:section>
-        <p14:section name="Chiusura" id="{fb679aca-bad8-700b-bec6-c00d922c40e3}">
+        <p14:section name="Chiusura" id="{ce1ed49b-d050-2e11-1970-bbc2a3b394b0}">
           <p14:sldIdLst>
             <p14:sldId id="267"/>
             <p14:sldId id="268"/>

</xml_diff>

<commit_message>
v1.7: stesso font e design dei docs RE OS
</commit_message>
<xml_diff>
--- a/AI Parte 1, Presentazione.pptx
+++ b/AI Parte 1, Presentazione.pptx
@@ -119,46 +119,46 @@
   <p:extLst>
     <p:ext uri="{521415D9-36F7-43E2-AB2F-B90AF26B5E84}">
       <p14:sectionLst xmlns:p14="http://schemas.microsoft.com/office/powerpoint/2010/main">
-        <p14:section name="Apertura" id="{44afbf48-d307-72d2-a021-a66cac9cbdda}">
+        <p14:section name="Apertura" id="{7087b253-69bd-ce71-77a7-a5718816fd05}">
           <p14:sldIdLst>
             <p14:sldId id="256"/>
             <p14:sldId id="257"/>
           </p14:sldIdLst>
         </p14:section>
-        <p14:section name="Perché" id="{245d62f3-830c-f04a-c490-1aaf9418d089}">
+        <p14:section name="Perché" id="{487b8028-f8eb-1396-7170-7fdcf9dcaf35}">
           <p14:sldIdLst>
             <p14:sldId id="258"/>
             <p14:sldId id="259"/>
             <p14:sldId id="260"/>
           </p14:sldIdLst>
         </p14:section>
-        <p14:section name="Capire" id="{8e9705c2-c46a-5fce-6e96-14becf825581}">
+        <p14:section name="Capire" id="{3d4c07d4-bd22-f721-23ac-08e48e7dac4a}">
           <p14:sldIdLst>
             <p14:sldId id="261"/>
           </p14:sldIdLst>
         </p14:section>
-        <p14:section name="Regole chiave" id="{42672046-1c30-4915-dd89-b207589e0704}">
+        <p14:section name="Regole chiave" id="{5473490e-0634-dcb3-301e-db537e52a3f0}">
           <p14:sldIdLst>
             <p14:sldId id="262"/>
           </p14:sldIdLst>
         </p14:section>
-        <p14:section name="In azienda" id="{9fc5b7c6-3977-aa78-097b-d8da3ee20ed2}">
+        <p14:section name="In azienda" id="{df4f8525-f876-da57-3aac-205454b17803}">
           <p14:sldIdLst>
             <p14:sldId id="263"/>
           </p14:sldIdLst>
         </p14:section>
-        <p14:section name="Il materiale" id="{9766cd91-c801-055f-fab1-ff59c2be33d4}">
+        <p14:section name="Il materiale" id="{3377b915-457e-fd19-400c-266ecafd1c4a}">
           <p14:sldIdLst>
             <p14:sldId id="264"/>
           </p14:sldIdLst>
         </p14:section>
-        <p14:section name="Adesso" id="{fa5be2f2-54dd-3547-0333-413858884d7d}">
+        <p14:section name="Adesso" id="{2e182571-040f-3cd3-fbf8-e434042e3fc7}">
           <p14:sldIdLst>
             <p14:sldId id="265"/>
             <p14:sldId id="266"/>
           </p14:sldIdLst>
         </p14:section>
-        <p14:section name="Chiusura" id="{ce1ed49b-d050-2e11-1970-bbc2a3b394b0}">
+        <p14:section name="Chiusura" id="{8e9f050c-686e-5dfc-95af-c44b8acb4155}">
           <p14:sldIdLst>
             <p14:sldId id="267"/>
             <p14:sldId id="268"/>

</xml_diff>